<commit_message>
Update pptx-design-agent demo gallery: rename BG demos for clarity, update Style08
- Rename background image demos with clearer Dark/Light/Coffee suffixes
- Remove old With_Background_Img-PPTX_Demo_Style08_Editorial_Magazine_BG.pptx
- Update PPTX_Demo_Style08_Editorial_Magazine.pptx

Co-Authored-By: Claude Haiku 4.5 <noreply@anthropic.com>
</commit_message>
<xml_diff>
--- a/curated/pptx-design-agent/demo/PPTX_Demo_Style08_Editorial_Magazine.pptx
+++ b/curated/pptx-design-agent/demo/PPTX_Demo_Style08_Editorial_Magazine.pptx
@@ -3152,7 +3152,7 @@
         <p:spPr>
           <a:xfrm>
             <a:off x="571500" y="600000"/>
-            <a:ext cx="11050000" cy="1800000"/>
+            <a:ext cx="11050000" cy="2673350"/>
           </a:xfrm>
           <a:prstGeom prst="rect">
             <a:avLst/>
@@ -3398,7 +3398,7 @@
         <p:spPr>
           <a:xfrm>
             <a:off x="571500" y="300000"/>
-            <a:ext cx="5000000" cy="1200000"/>
+            <a:ext cx="5000000" cy="2197100"/>
           </a:xfrm>
           <a:prstGeom prst="rect">
             <a:avLst/>
@@ -3475,7 +3475,7 @@
         </p:nvSpPr>
         <p:spPr>
           <a:xfrm>
-            <a:off x="571500" y="1900000"/>
+            <a:off x="571500" y="2547900"/>
             <a:ext cx="5000000" cy="800000"/>
           </a:xfrm>
           <a:prstGeom prst="rect">
@@ -4580,7 +4580,7 @@
         <p:spPr>
           <a:xfrm>
             <a:off x="571500" y="300000"/>
-            <a:ext cx="4500000" cy="1200000"/>
+            <a:ext cx="4500000" cy="1625600"/>
           </a:xfrm>
           <a:prstGeom prst="rect">
             <a:avLst/>
@@ -4656,7 +4656,7 @@
         </p:nvSpPr>
         <p:spPr>
           <a:xfrm>
-            <a:off x="571500" y="1900000"/>
+            <a:off x="571500" y="1976400"/>
             <a:ext cx="4500000" cy="600000"/>
           </a:xfrm>
           <a:prstGeom prst="rect">
@@ -4777,7 +4777,7 @@
         <p:spPr>
           <a:xfrm>
             <a:off x="5900000" y="550000"/>
-            <a:ext cx="5800000" cy="280000"/>
+            <a:ext cx="5800000" cy="419100"/>
           </a:xfrm>
           <a:prstGeom prst="rect">
             <a:avLst/>
@@ -4827,7 +4827,7 @@
         </p:nvSpPr>
         <p:spPr>
           <a:xfrm>
-            <a:off x="6600000" y="900000"/>
+            <a:off x="6600000" y="1019900"/>
             <a:ext cx="5100000" cy="400000"/>
           </a:xfrm>
           <a:prstGeom prst="rect">
@@ -4904,7 +4904,7 @@
         <p:spPr>
           <a:xfrm>
             <a:off x="5900000" y="1650000"/>
-            <a:ext cx="5800000" cy="280000"/>
+            <a:ext cx="5800000" cy="419100"/>
           </a:xfrm>
           <a:prstGeom prst="rect">
             <a:avLst/>
@@ -4954,7 +4954,7 @@
         </p:nvSpPr>
         <p:spPr>
           <a:xfrm>
-            <a:off x="6600000" y="2000000"/>
+            <a:off x="6600000" y="2119900"/>
             <a:ext cx="5100000" cy="400000"/>
           </a:xfrm>
           <a:prstGeom prst="rect">
@@ -5031,7 +5031,7 @@
         <p:spPr>
           <a:xfrm>
             <a:off x="5900000" y="2750000"/>
-            <a:ext cx="5800000" cy="280000"/>
+            <a:ext cx="5800000" cy="419100"/>
           </a:xfrm>
           <a:prstGeom prst="rect">
             <a:avLst/>
@@ -5081,7 +5081,7 @@
         </p:nvSpPr>
         <p:spPr>
           <a:xfrm>
-            <a:off x="6600000" y="3100000"/>
+            <a:off x="6600000" y="3219900"/>
             <a:ext cx="5100000" cy="400000"/>
           </a:xfrm>
           <a:prstGeom prst="rect">
@@ -5158,7 +5158,7 @@
         <p:spPr>
           <a:xfrm>
             <a:off x="5900000" y="3850000"/>
-            <a:ext cx="5800000" cy="280000"/>
+            <a:ext cx="5800000" cy="419100"/>
           </a:xfrm>
           <a:prstGeom prst="rect">
             <a:avLst/>
@@ -5208,7 +5208,7 @@
         </p:nvSpPr>
         <p:spPr>
           <a:xfrm>
-            <a:off x="6600000" y="4200000"/>
+            <a:off x="6600000" y="4319900"/>
             <a:ext cx="5100000" cy="400000"/>
           </a:xfrm>
           <a:prstGeom prst="rect">
@@ -5285,7 +5285,7 @@
         <p:spPr>
           <a:xfrm>
             <a:off x="5900000" y="4950000"/>
-            <a:ext cx="5800000" cy="280000"/>
+            <a:ext cx="5800000" cy="419100"/>
           </a:xfrm>
           <a:prstGeom prst="rect">
             <a:avLst/>
@@ -5335,7 +5335,7 @@
         </p:nvSpPr>
         <p:spPr>
           <a:xfrm>
-            <a:off x="6600000" y="5300000"/>
+            <a:off x="6600000" y="5419900"/>
             <a:ext cx="5100000" cy="400000"/>
           </a:xfrm>
           <a:prstGeom prst="rect">
@@ -5471,7 +5471,7 @@
         <p:spPr>
           <a:xfrm>
             <a:off x="571500" y="350000"/>
-            <a:ext cx="11050000" cy="800000"/>
+            <a:ext cx="11050000" cy="1219200"/>
           </a:xfrm>
           <a:prstGeom prst="rect">
             <a:avLst/>
@@ -5504,7 +5504,7 @@
         </p:nvSpPr>
         <p:spPr>
           <a:xfrm>
-            <a:off x="571500" y="1250000"/>
+            <a:off x="571500" y="1625600"/>
             <a:ext cx="11050000" cy="36576"/>
           </a:xfrm>
           <a:prstGeom prst="rect">
@@ -5547,8 +5547,8 @@
         </p:nvSpPr>
         <p:spPr>
           <a:xfrm>
-            <a:off x="571500" y="1450000"/>
-            <a:ext cx="250000" cy="800000"/>
+            <a:off x="571500" y="1790700"/>
+            <a:ext cx="250000" cy="800100"/>
           </a:xfrm>
           <a:prstGeom prst="rect">
             <a:avLst/>
@@ -5590,8 +5590,8 @@
         </p:nvSpPr>
         <p:spPr>
           <a:xfrm>
-            <a:off x="1000000" y="1480000"/>
-            <a:ext cx="3000000" cy="500000"/>
+            <a:off x="1000000" y="1854200"/>
+            <a:ext cx="3000000" cy="673100"/>
           </a:xfrm>
           <a:prstGeom prst="rect">
             <a:avLst/>
@@ -5623,7 +5623,7 @@
         </p:nvSpPr>
         <p:spPr>
           <a:xfrm>
-            <a:off x="4200000" y="1500000"/>
+            <a:off x="4200000" y="2146300"/>
             <a:ext cx="3000000" cy="350000"/>
           </a:xfrm>
           <a:prstGeom prst="rect">
@@ -5656,7 +5656,7 @@
         </p:nvSpPr>
         <p:spPr>
           <a:xfrm>
-            <a:off x="4200000" y="1870000"/>
+            <a:off x="4200000" y="1841500"/>
             <a:ext cx="7400000" cy="350000"/>
           </a:xfrm>
           <a:prstGeom prst="rect">
@@ -5689,7 +5689,7 @@
         </p:nvSpPr>
         <p:spPr>
           <a:xfrm>
-            <a:off x="571500" y="2280000"/>
+            <a:off x="571500" y="2616200"/>
             <a:ext cx="11050000" cy="18288"/>
           </a:xfrm>
           <a:prstGeom prst="rect">
@@ -5732,8 +5732,8 @@
         </p:nvSpPr>
         <p:spPr>
           <a:xfrm>
-            <a:off x="571500" y="2350000"/>
-            <a:ext cx="250000" cy="800000"/>
+            <a:off x="571500" y="2692400"/>
+            <a:ext cx="250000" cy="800100"/>
           </a:xfrm>
           <a:prstGeom prst="rect">
             <a:avLst/>
@@ -5775,8 +5775,8 @@
         </p:nvSpPr>
         <p:spPr>
           <a:xfrm>
-            <a:off x="1000000" y="2380000"/>
-            <a:ext cx="3000000" cy="500000"/>
+            <a:off x="1000000" y="2755900"/>
+            <a:ext cx="3000000" cy="673100"/>
           </a:xfrm>
           <a:prstGeom prst="rect">
             <a:avLst/>
@@ -5808,7 +5808,7 @@
         </p:nvSpPr>
         <p:spPr>
           <a:xfrm>
-            <a:off x="4200000" y="2400000"/>
+            <a:off x="4200000" y="3048000"/>
             <a:ext cx="3000000" cy="350000"/>
           </a:xfrm>
           <a:prstGeom prst="rect">
@@ -5841,7 +5841,7 @@
         </p:nvSpPr>
         <p:spPr>
           <a:xfrm>
-            <a:off x="4200000" y="2770000"/>
+            <a:off x="4200000" y="2743200"/>
             <a:ext cx="7400000" cy="350000"/>
           </a:xfrm>
           <a:prstGeom prst="rect">
@@ -5874,7 +5874,7 @@
         </p:nvSpPr>
         <p:spPr>
           <a:xfrm>
-            <a:off x="571500" y="3180000"/>
+            <a:off x="571500" y="3517900"/>
             <a:ext cx="11050000" cy="18288"/>
           </a:xfrm>
           <a:prstGeom prst="rect">
@@ -5917,8 +5917,8 @@
         </p:nvSpPr>
         <p:spPr>
           <a:xfrm>
-            <a:off x="571500" y="3250000"/>
-            <a:ext cx="250000" cy="800000"/>
+            <a:off x="571500" y="3594100"/>
+            <a:ext cx="250000" cy="800100"/>
           </a:xfrm>
           <a:prstGeom prst="rect">
             <a:avLst/>
@@ -5960,8 +5960,8 @@
         </p:nvSpPr>
         <p:spPr>
           <a:xfrm>
-            <a:off x="1000000" y="3280000"/>
-            <a:ext cx="3000000" cy="500000"/>
+            <a:off x="1000000" y="3657600"/>
+            <a:ext cx="3000000" cy="673100"/>
           </a:xfrm>
           <a:prstGeom prst="rect">
             <a:avLst/>
@@ -5993,7 +5993,7 @@
         </p:nvSpPr>
         <p:spPr>
           <a:xfrm>
-            <a:off x="4200000" y="3300000"/>
+            <a:off x="4200000" y="3949700"/>
             <a:ext cx="3000000" cy="350000"/>
           </a:xfrm>
           <a:prstGeom prst="rect">
@@ -6026,7 +6026,7 @@
         </p:nvSpPr>
         <p:spPr>
           <a:xfrm>
-            <a:off x="4200000" y="3670000"/>
+            <a:off x="4200000" y="3644900"/>
             <a:ext cx="7400000" cy="350000"/>
           </a:xfrm>
           <a:prstGeom prst="rect">
@@ -6059,7 +6059,7 @@
         </p:nvSpPr>
         <p:spPr>
           <a:xfrm>
-            <a:off x="571500" y="4080000"/>
+            <a:off x="571500" y="4419600"/>
             <a:ext cx="11050000" cy="18288"/>
           </a:xfrm>
           <a:prstGeom prst="rect">
@@ -6102,8 +6102,8 @@
         </p:nvSpPr>
         <p:spPr>
           <a:xfrm>
-            <a:off x="571500" y="4150000"/>
-            <a:ext cx="250000" cy="800000"/>
+            <a:off x="571500" y="4495800"/>
+            <a:ext cx="250000" cy="800100"/>
           </a:xfrm>
           <a:prstGeom prst="rect">
             <a:avLst/>
@@ -6145,8 +6145,8 @@
         </p:nvSpPr>
         <p:spPr>
           <a:xfrm>
-            <a:off x="1000000" y="4180000"/>
-            <a:ext cx="3000000" cy="500000"/>
+            <a:off x="1000000" y="4559300"/>
+            <a:ext cx="3000000" cy="673100"/>
           </a:xfrm>
           <a:prstGeom prst="rect">
             <a:avLst/>
@@ -6178,7 +6178,7 @@
         </p:nvSpPr>
         <p:spPr>
           <a:xfrm>
-            <a:off x="4200000" y="4200000"/>
+            <a:off x="4200000" y="4851400"/>
             <a:ext cx="3000000" cy="350000"/>
           </a:xfrm>
           <a:prstGeom prst="rect">
@@ -6211,7 +6211,7 @@
         </p:nvSpPr>
         <p:spPr>
           <a:xfrm>
-            <a:off x="4200000" y="4570000"/>
+            <a:off x="4200000" y="4546600"/>
             <a:ext cx="7400000" cy="350000"/>
           </a:xfrm>
           <a:prstGeom prst="rect">
@@ -6244,7 +6244,7 @@
         </p:nvSpPr>
         <p:spPr>
           <a:xfrm>
-            <a:off x="571500" y="4980000"/>
+            <a:off x="571500" y="5321300"/>
             <a:ext cx="11050000" cy="18288"/>
           </a:xfrm>
           <a:prstGeom prst="rect">
@@ -6287,8 +6287,8 @@
         </p:nvSpPr>
         <p:spPr>
           <a:xfrm>
-            <a:off x="571500" y="5050000"/>
-            <a:ext cx="250000" cy="800000"/>
+            <a:off x="571500" y="5397500"/>
+            <a:ext cx="250000" cy="800100"/>
           </a:xfrm>
           <a:prstGeom prst="rect">
             <a:avLst/>
@@ -6330,8 +6330,8 @@
         </p:nvSpPr>
         <p:spPr>
           <a:xfrm>
-            <a:off x="1000000" y="5080000"/>
-            <a:ext cx="3000000" cy="500000"/>
+            <a:off x="1000000" y="5461000"/>
+            <a:ext cx="3000000" cy="673100"/>
           </a:xfrm>
           <a:prstGeom prst="rect">
             <a:avLst/>
@@ -6363,7 +6363,7 @@
         </p:nvSpPr>
         <p:spPr>
           <a:xfrm>
-            <a:off x="4200000" y="5100000"/>
+            <a:off x="4200000" y="5753100"/>
             <a:ext cx="3000000" cy="350000"/>
           </a:xfrm>
           <a:prstGeom prst="rect">
@@ -6396,7 +6396,7 @@
         </p:nvSpPr>
         <p:spPr>
           <a:xfrm>
-            <a:off x="4200000" y="5470000"/>
+            <a:off x="4200000" y="5448300"/>
             <a:ext cx="7400000" cy="350000"/>
           </a:xfrm>
           <a:prstGeom prst="rect">
@@ -6429,7 +6429,7 @@
         </p:nvSpPr>
         <p:spPr>
           <a:xfrm>
-            <a:off x="571500" y="5880000"/>
+            <a:off x="571500" y="6223000"/>
             <a:ext cx="11050000" cy="18288"/>
           </a:xfrm>
           <a:prstGeom prst="rect">
@@ -6472,7 +6472,7 @@
         </p:nvSpPr>
         <p:spPr>
           <a:xfrm>
-            <a:off x="571500" y="6400000"/>
+            <a:off x="571500" y="6489700"/>
             <a:ext cx="11050000" cy="300000"/>
           </a:xfrm>
           <a:prstGeom prst="rect">
@@ -6575,7 +6575,7 @@
         <p:spPr>
           <a:xfrm>
             <a:off x="571500" y="1500000"/>
-            <a:ext cx="11050000" cy="1500000"/>
+            <a:ext cx="11050000" cy="1816100"/>
           </a:xfrm>
           <a:prstGeom prst="rect">
             <a:avLst/>

</xml_diff>